<commit_message>
Add author name to title slide
Co-Authored-By: Claude Sonnet 5.5 <noreply@anthropic.com>
Claude-Session: https://claude.ai/code/session_01YRcHuGSLX9N1PNfKhtRhK6
</commit_message>
<xml_diff>
--- a/presentations/green-chemistry-principle-8.pptx
+++ b/presentations/green-chemistry-principle-8.pptx
@@ -121,7 +121,7 @@
   <p:extLst>
     <p:ext uri="{521415D9-36F7-43E2-AB2F-B90AF26B5E84}">
       <p14:sectionLst xmlns:p14="http://schemas.microsoft.com/office/powerpoint/2010/main">
-        <p14:section name="Кіріспе" id="{d7611761-a8b3-e7aa-98b8-ea67360268ef}">
+        <p14:section name="Кіріспе" id="{126e5213-be0d-5f93-1b34-590ecb4877a9}">
           <p14:sldIdLst>
             <p14:sldId id="256"/>
             <p14:sldId id="257"/>
@@ -129,13 +129,13 @@
             <p14:sldId id="259"/>
           </p14:sldIdLst>
         </p14:section>
-        <p14:section name="Мысалдар" id="{ac2a3174-169f-51d4-dc7b-ed44c4a26cf8}">
+        <p14:section name="Мысалдар" id="{431a8429-cf74-b1c5-866a-557b04671093}">
           <p14:sldIdLst>
             <p14:sldId id="260"/>
             <p14:sldId id="261"/>
           </p14:sldIdLst>
         </p14:section>
-        <p14:section name="Әлем" id="{895c48b2-cb16-2db2-4164-0ef10bf9dd22}">
+        <p14:section name="Әлем" id="{c84689b6-e55c-a930-347b-7565cce1acef}">
           <p14:sldIdLst>
             <p14:sldId id="262"/>
             <p14:sldId id="263"/>
@@ -143,7 +143,7 @@
             <p14:sldId id="265"/>
           </p14:sldIdLst>
         </p14:section>
-        <p14:section name="Қазақстан" id="{c1f7b863-f5d5-8365-6892-ce88a70fe3a2}">
+        <p14:section name="Қазақстан" id="{2a7242c6-b4ef-bcbd-c5b4-57f20e5f937f}">
           <p14:sldIdLst>
             <p14:sldId id="266"/>
             <p14:sldId id="267"/>
@@ -151,7 +151,7 @@
             <p14:sldId id="269"/>
           </p14:sldIdLst>
         </p14:section>
-        <p14:section name="Қорытынды" id="{f9506fe7-123d-f6e3-ecfb-393c09b8604f}">
+        <p14:section name="Қорытынды" id="{62e9f8a7-043b-1a07-426c-f9f81e2c00ae}">
           <p14:sldIdLst>
             <p14:sldId id="270"/>
           </p14:sldIdLst>
@@ -2508,7 +2508,43 @@
       </p:sp>
       <p:sp>
         <p:nvSpPr>
-          <p:cNvPr id="5" name="circle"/>
+          <p:cNvPr id="5" name="Text 3"/>
+          <p:cNvSpPr txBox="1"/>
+          <p:nvPr/>
+        </p:nvSpPr>
+        <p:spPr>
+          <a:xfrm>
+            <a:off x="548640" y="4297680"/>
+            <a:ext cx="5120640" cy="365760"/>
+          </a:xfrm>
+          <a:prstGeom prst="rect">
+            <a:avLst/>
+          </a:prstGeom>
+          <a:noFill/>
+          <a:ln/>
+        </p:spPr>
+        <p:txBody>
+          <a:bodyPr wrap="square" lIns="0" tIns="0" rIns="0" bIns="0" rtlCol="0" anchor="t"/>
+          <a:lstStyle/>
+          <a:p>
+            <a:pPr indent="0" marL="0">
+              <a:buNone/>
+            </a:pPr>
+            <a:r>
+              <a:rPr lang="en-US" sz="1600" b="1" dirty="0">
+                <a:solidFill>
+                  <a:schemeClr val="bg1"/>
+                </a:solidFill>
+              </a:rPr>
+              <a:t>Орындаған: Нұржанқызы Айкерім</a:t>
+            </a:r>
+            <a:endParaRPr lang="en-US" sz="1600" dirty="0"/>
+          </a:p>
+        </p:txBody>
+      </p:sp>
+      <p:sp>
+        <p:nvSpPr>
+          <p:cNvPr id="6" name="circle"/>
           <p:cNvSpPr/>
           <p:nvPr/>
         </p:nvSpPr>
@@ -2533,7 +2569,7 @@
       </p:sp>
       <p:sp>
         <p:nvSpPr>
-          <p:cNvPr id="6" name="Text 4"/>
+          <p:cNvPr id="7" name="Text 5"/>
           <p:cNvSpPr txBox="1"/>
           <p:nvPr/>
         </p:nvSpPr>
@@ -2572,7 +2608,7 @@
       </p:sp>
       <p:sp>
         <p:nvSpPr>
-          <p:cNvPr id="7" name="circle"/>
+          <p:cNvPr id="8" name="circle"/>
           <p:cNvSpPr/>
           <p:nvPr/>
         </p:nvSpPr>
@@ -2597,7 +2633,7 @@
       </p:sp>
       <p:sp>
         <p:nvSpPr>
-          <p:cNvPr id="8" name="Text 6"/>
+          <p:cNvPr id="9" name="Text 7"/>
           <p:cNvSpPr txBox="1"/>
           <p:nvPr/>
         </p:nvSpPr>
@@ -2625,7 +2661,7 @@
       </p:sp>
       <p:sp>
         <p:nvSpPr>
-          <p:cNvPr id="9" name="circle"/>
+          <p:cNvPr id="10" name="circle"/>
           <p:cNvSpPr/>
           <p:nvPr/>
         </p:nvSpPr>
@@ -2650,7 +2686,7 @@
       </p:sp>
       <p:sp>
         <p:nvSpPr>
-          <p:cNvPr id="10" name="Text 8"/>
+          <p:cNvPr id="11" name="Text 9"/>
           <p:cNvSpPr txBox="1"/>
           <p:nvPr/>
         </p:nvSpPr>
@@ -2678,7 +2714,7 @@
       </p:sp>
       <p:sp>
         <p:nvSpPr>
-          <p:cNvPr id="11" name="circle"/>
+          <p:cNvPr id="12" name="circle"/>
           <p:cNvSpPr/>
           <p:nvPr/>
         </p:nvSpPr>
@@ -2703,7 +2739,7 @@
       </p:sp>
       <p:sp>
         <p:nvSpPr>
-          <p:cNvPr id="12" name="Text 10"/>
+          <p:cNvPr id="13" name="Text 11"/>
           <p:cNvSpPr txBox="1"/>
           <p:nvPr/>
         </p:nvSpPr>
@@ -2731,7 +2767,7 @@
       </p:sp>
       <p:sp>
         <p:nvSpPr>
-          <p:cNvPr id="14" name="Text 0"/>
+          <p:cNvPr id="15" name="Text 0"/>
           <p:cNvSpPr/>
           <p:nvPr>
             <p:ph idx="100" type="title" hasCustomPrompt="1"/>

</xml_diff>